<commit_message>
fix: final-review findings — injection-success sample, median latency, judge PII exposure, circuit breaker, fallback-safe answer quality; regenerate deliverables
Co-Authored-By: Claude Opus 5.5 <noreply@anthropic.com>
</commit_message>
<xml_diff>
--- a/deliverables/Copilot Privacy Guard - Final.pptx
+++ b/deliverables/Copilot Privacy Guard - Final.pptx
@@ -2674,7 +2674,7 @@
           <a:lstStyle/>
           <a:p>
             <a:r>
-              <a:t>Same retriever, same LLM. PII sent to the provider drops from 100% to zero, over-sharing from 50.9% to zero, raw PII in the index and poisoned chunks reaching the model both to zero. The honest part is the last two rows: answer-quality retention falls to 34.9% and the judge costs about 0.8 seconds per query. Note the LLM itself obeyed almost no canaries — model resistance isn't something the deployer controls, so we design for zero exposure instead.</a:t>
+              <a:t>Same retriever, same LLM. PII sent to the provider drops from 100% to zero, over-sharing from 50.9% to zero, raw PII in the index and poisoned chunks reaching the model both to zero. The honest part is the last two rows: answer-quality retention falls to 34.9% and each uncached judge call takes about 553 ms. Note the LLM itself obeyed almost no canaries — model resistance isn't something the deployer controls, so we design for zero exposure instead.</a:t>
             </a:r>
           </a:p>
         </p:txBody>
@@ -9426,7 +9426,7 @@
                           </a:solidFill>
                           <a:latin typeface="IBM Plex Sans"/>
                         </a:rPr>
-                        <a:t>-1 ms</a:t>
+                        <a:t>-0 ms</a:t>
                       </a:r>
                     </a:p>
                   </a:txBody>
@@ -9708,7 +9708,7 @@
                           </a:solidFill>
                           <a:latin typeface="IBM Plex Sans"/>
                         </a:rPr>
-                        <a:t>+46 ms</a:t>
+                        <a:t>+40 ms</a:t>
                       </a:r>
                     </a:p>
                   </a:txBody>
@@ -9990,7 +9990,7 @@
                           </a:solidFill>
                           <a:latin typeface="IBM Plex Sans"/>
                         </a:rPr>
-                        <a:t>+11 ms</a:t>
+                        <a:t>+8 ms</a:t>
                       </a:r>
                     </a:p>
                   </a:txBody>
@@ -10272,7 +10272,7 @@
                           </a:solidFill>
                           <a:latin typeface="IBM Plex Sans"/>
                         </a:rPr>
-                        <a:t>-1 ms</a:t>
+                        <a:t>-0 ms</a:t>
                       </a:r>
                     </a:p>
                   </a:txBody>
@@ -10554,7 +10554,7 @@
                           </a:solidFill>
                           <a:latin typeface="IBM Plex Sans"/>
                         </a:rPr>
-                        <a:t>-1 ms</a:t>
+                        <a:t>-0 ms</a:t>
                       </a:r>
                     </a:p>
                   </a:txBody>
@@ -10836,7 +10836,7 @@
                           </a:solidFill>
                           <a:latin typeface="IBM Plex Sans"/>
                         </a:rPr>
-                        <a:t>+815 ms</a:t>
+                        <a:t>+97 ms</a:t>
                       </a:r>
                     </a:p>
                   </a:txBody>
@@ -11606,7 +11606,7 @@
                           </a:solidFill>
                           <a:latin typeface="IBM Plex Sans"/>
                         </a:rPr>
-                        <a:t>+815 ms</a:t>
+                        <a:t>+97 ms</a:t>
                       </a:r>
                     </a:p>
                   </a:txBody>
@@ -11888,7 +11888,7 @@
                           </a:solidFill>
                           <a:latin typeface="IBM Plex Sans"/>
                         </a:rPr>
-                        <a:t>+382 ms</a:t>
+                        <a:t>+121 ms</a:t>
                       </a:r>
                     </a:p>
                   </a:txBody>
@@ -11970,7 +11970,7 @@
                           </a:solidFill>
                           <a:latin typeface="IBM Plex Sans"/>
                         </a:rPr>
-                        <a:t>41%</a:t>
+                        <a:t>49%</a:t>
                       </a:r>
                     </a:p>
                   </a:txBody>
@@ -12170,7 +12170,7 @@
                           </a:solidFill>
                           <a:latin typeface="IBM Plex Sans"/>
                         </a:rPr>
-                        <a:t>+1899 ms</a:t>
+                        <a:t>+58 ms</a:t>
                       </a:r>
                     </a:p>
                   </a:txBody>
@@ -12452,7 +12452,7 @@
                           </a:solidFill>
                           <a:latin typeface="IBM Plex Sans"/>
                         </a:rPr>
-                        <a:t>+123 ms</a:t>
+                        <a:t>+98 ms</a:t>
                       </a:r>
                     </a:p>
                   </a:txBody>
@@ -12734,7 +12734,7 @@
                           </a:solidFill>
                           <a:latin typeface="IBM Plex Sans"/>
                         </a:rPr>
-                        <a:t>+106 ms</a:t>
+                        <a:t>+98 ms</a:t>
                       </a:r>
                     </a:p>
                   </a:txBody>
@@ -13016,7 +13016,7 @@
                           </a:solidFill>
                           <a:latin typeface="IBM Plex Sans"/>
                         </a:rPr>
-                        <a:t>+621 ms</a:t>
+                        <a:t>+130 ms</a:t>
                       </a:r>
                     </a:p>
                   </a:txBody>
@@ -13099,7 +13099,7 @@
                 </a:solidFill>
                 <a:latin typeface="IBM Plex Sans"/>
               </a:rPr>
-              <a:t>Drop redaction → 41% of PII reaches the provider and the index holds all of it.</a:t>
+              <a:t>Drop redaction → 49% of PII reaches the provider and the index holds all of it.</a:t>
             </a:r>
           </a:p>
           <a:p>
@@ -13131,7 +13131,7 @@
                 </a:solidFill>
                 <a:latin typeface="IBM Plex Sans"/>
               </a:rPr>
-              <a:t>Drop the judge → same corpus metrics, latency +106 ms — its value shows on harder payloads (next slides).</a:t>
+              <a:t>Drop the judge → same corpus metrics, latency +98 ms — its value shows on harder payloads (next slides).</a:t>
             </a:r>
           </a:p>
         </p:txBody>
@@ -23195,7 +23195,7 @@
                           </a:solidFill>
                           <a:latin typeface="IBM Plex Sans"/>
                         </a:rPr>
-                        <a:t>Injection success — canary obeyed by the LLM (14 attacked queries)</a:t>
+                        <a:t>Injection success — canary obeyed by the LLM (injection queries)</a:t>
                       </a:r>
                     </a:p>
                   </a:txBody>
@@ -23561,7 +23561,7 @@
                           </a:solidFill>
                           <a:latin typeface="IBM Plex Sans"/>
                         </a:rPr>
-                        <a:t>Added latency per query</a:t>
+                        <a:t>Added latency per query (median)</a:t>
                       </a:r>
                     </a:p>
                   </a:txBody>
@@ -23641,7 +23641,7 @@
                           </a:solidFill>
                           <a:latin typeface="IBM Plex Sans"/>
                         </a:rPr>
-                        <a:t>+815 ms</a:t>
+                        <a:t>+97 ms</a:t>
                       </a:r>
                     </a:p>
                   </a:txBody>
@@ -24440,7 +24440,7 @@
                 <a:ea typeface="IBM Plex Sans" pitchFamily="34" charset="-122"/>
                 <a:cs typeface="IBM Plex Sans" pitchFamily="34" charset="-120"/>
               </a:rPr>
-              <a:t>Latency — the LLM judge adds ~0.7 s per query; caching and batching would cut it.</a:t>
+              <a:t>Latency — median +97 ms per query with caches; each uncached judge call takes ~553 ms.</a:t>
             </a:r>
             <a:endParaRPr lang="en-US" sz="1300" dirty="0"/>
           </a:p>

</xml_diff>